<commit_message>
fix: correct stale "seven-tab" claims in presentation to eight tabs
The Streamlit app gained a Semantic tab in the pipeline-wiring commit,
making the "seven-tab dashboard" line in the Interfaces slide stale.
The demo slide's tab list was already wrong before that (it named tabs
that don't exist in app.py -- "overview", "impact", "readiness
summary" -- instead of the real ones); replaced with the actual eight:
quality, leakage, features, sufficiency, drift, semantic (LLM),
recommendations, download.

Co-Authored-By: Claude Fable 5 <noreply@anthropic.com>
</commit_message>
<xml_diff>
--- a/presentation.pptx
+++ b/presentation.pptx
@@ -6079,7 +6079,7 @@
                   <a:srgbClr val="262626"/>
                 </a:solidFill>
               </a:rPr>
-              <a:t>seven-tab dashboard for non-programmers</a:t>
+              <a:t>eight-tab dashboard for non-programmers</a:t>
             </a:r>
           </a:p>
         </p:txBody>
@@ -18957,7 +18957,7 @@
                   <a:srgbClr val="555555"/>
                 </a:solidFill>
               </a:rPr>
-              <a:t>Seven tabs: overview, quality, leakage, features, sufficiency, impact, readiness summary.</a:t>
+              <a:t>Eight tabs: quality, leakage, features, sufficiency, drift, semantic (LLM), recommendations, download.</a:t>
             </a:r>
           </a:p>
           <a:p>

</xml_diff>